<commit_message>
작업: 6/4 megasession — _inbox 6장 흡수 (revita 3장 + ondevice 3장, 결정 40~43 신설 + 9 함정 + 2 thought) + 한국기계 AI 교육 풀세트 제작 (커리큘럼/시나리오/PPTX/MP4 6분/HTML/PDF + 빌드 스크립트 4종, 위시캣 SOP 결정 39 2번째 적용) + 전화번호 환각 발견·일괄 수정 (010-7186→010-2401-9059, 메모리 박제 2건 reference_user_phone + feedback_no_fabricated_user_data) + 동아정밀 fact 검증 7건 의문점 carry
Co-Authored-By: Claude Opus 4.7 (1M context) <noreply@anthropic.com>
</commit_message>
<xml_diff>
--- a/동영상/동아정밀_미팅/동아정밀_PET두께측정기_제안.pptx
+++ b/동영상/동아정밀_미팅/동아정밀_PET두께측정기_제안.pptx
@@ -4791,7 +4791,7 @@
                 </a:solidFill>
                 <a:latin typeface="맑은 고딕"/>
               </a:rPr>
-              <a:t>UTTEC · 홍광선  ihong9059@gmail.com · 010-7186-2452 · 경기 용인시 기흥구 흥덕유타워</a:t>
+              <a:t>UTTEC · 홍광선  ihong9059@gmail.com · 010-2401-9059 · 경기 용인시 기흥구 흥덕유타워</a:t>
             </a:r>
           </a:p>
         </p:txBody>
@@ -6657,7 +6657,7 @@
                 </a:solidFill>
                 <a:latin typeface="맑은 고딕"/>
               </a:rPr>
-              <a:t>UTTEC · 홍광선  ihong9059@gmail.com · 010-7186-2452 · 경기 용인시 기흥구 흥덕유타워</a:t>
+              <a:t>UTTEC · 홍광선  ihong9059@gmail.com · 010-2401-9059 · 경기 용인시 기흥구 흥덕유타워</a:t>
             </a:r>
           </a:p>
         </p:txBody>
@@ -7797,7 +7797,7 @@
                 </a:solidFill>
                 <a:latin typeface="맑은 고딕"/>
               </a:rPr>
-              <a:t>UTTEC · 홍광선  ihong9059@gmail.com · 010-7186-2452 · 경기 용인시 기흥구 흥덕유타워</a:t>
+              <a:t>UTTEC · 홍광선  ihong9059@gmail.com · 010-2401-9059 · 경기 용인시 기흥구 흥덕유타워</a:t>
             </a:r>
           </a:p>
         </p:txBody>
@@ -8595,7 +8595,7 @@
                 </a:solidFill>
                 <a:latin typeface="맑은 고딕"/>
               </a:rPr>
-              <a:t>UTTEC · 홍광선  ihong9059@gmail.com · 010-7186-2452 · 경기 용인시 기흥구 흥덕유타워</a:t>
+              <a:t>UTTEC · 홍광선  ihong9059@gmail.com · 010-2401-9059 · 경기 용인시 기흥구 흥덕유타워</a:t>
             </a:r>
           </a:p>
         </p:txBody>
@@ -10310,7 +10310,7 @@
                 </a:solidFill>
                 <a:latin typeface="맑은 고딕"/>
               </a:rPr>
-              <a:t>UTTEC · 홍광선  ihong9059@gmail.com · 010-7186-2452 · 경기 용인시 기흥구 흥덕유타워</a:t>
+              <a:t>UTTEC · 홍광선  ihong9059@gmail.com · 010-2401-9059 · 경기 용인시 기흥구 흥덕유타워</a:t>
             </a:r>
           </a:p>
         </p:txBody>
@@ -12221,7 +12221,7 @@
                 </a:solidFill>
                 <a:latin typeface="맑은 고딕"/>
               </a:rPr>
-              <a:t>UTTEC · 홍광선  ihong9059@gmail.com · 010-7186-2452 · 경기 용인시 기흥구 흥덕유타워</a:t>
+              <a:t>UTTEC · 홍광선  ihong9059@gmail.com · 010-2401-9059 · 경기 용인시 기흥구 흥덕유타워</a:t>
             </a:r>
           </a:p>
         </p:txBody>
@@ -13366,7 +13366,7 @@
                 </a:solidFill>
                 <a:latin typeface="맑은 고딕"/>
               </a:rPr>
-              <a:t>UTTEC · 홍광선  ihong9059@gmail.com · 010-7186-2452 · 경기 용인시 기흥구 흥덕유타워</a:t>
+              <a:t>UTTEC · 홍광선  ihong9059@gmail.com · 010-2401-9059 · 경기 용인시 기흥구 흥덕유타워</a:t>
             </a:r>
           </a:p>
         </p:txBody>
@@ -14531,7 +14531,7 @@
                 </a:solidFill>
                 <a:latin typeface="맑은 고딕"/>
               </a:rPr>
-              <a:t>UTTEC · 홍광선  ihong9059@gmail.com · 010-7186-2452 · 경기 용인시 기흥구 흥덕유타워</a:t>
+              <a:t>UTTEC · 홍광선  ihong9059@gmail.com · 010-2401-9059 · 경기 용인시 기흥구 흥덕유타워</a:t>
             </a:r>
           </a:p>
         </p:txBody>
@@ -16113,7 +16113,7 @@
                 </a:solidFill>
                 <a:latin typeface="맑은 고딕"/>
               </a:rPr>
-              <a:t>UTTEC · 홍광선  ihong9059@gmail.com · 010-7186-2452 · 경기 용인시 기흥구 흥덕유타워</a:t>
+              <a:t>UTTEC · 홍광선  ihong9059@gmail.com · 010-2401-9059 · 경기 용인시 기흥구 흥덕유타워</a:t>
             </a:r>
           </a:p>
         </p:txBody>

</xml_diff>